<commit_message>
Fix all logical, accounting, security rules, and cross-platform issues; optimize web build
</commit_message>
<xml_diff>
--- a/BharatDues_App_Guide.pptx
+++ b/BharatDues_App_Guide.pptx
@@ -3162,7 +3162,7 @@
                 </a:solidFill>
                 <a:latin typeface="Aptos"/>
               </a:rPr>
-              <a:t>Bharat Dues • 2026-04-16</a:t>
+              <a:t>Bharat Dues • 2026-04-26</a:t>
             </a:r>
           </a:p>
         </p:txBody>
@@ -3341,7 +3341,7 @@
                 </a:solidFill>
                 <a:latin typeface="Aptos"/>
               </a:rPr>
-              <a:t>Bharat Dues • 2026-04-16</a:t>
+              <a:t>Bharat Dues • 2026-04-26</a:t>
             </a:r>
           </a:p>
         </p:txBody>
@@ -3418,7 +3418,7 @@
                 </a:solidFill>
                 <a:latin typeface="Aptos"/>
               </a:rPr>
-              <a:t>Settle Up (UPI-first flow)</a:t>
+              <a:t>Unified Global Settlement</a:t>
             </a:r>
           </a:p>
         </p:txBody>
@@ -3521,7 +3521,7 @@
                 </a:solidFill>
                 <a:latin typeface="Aptos"/>
               </a:rPr>
-              <a:t>If no UPI ID is available: record a manual payment and reconcile later</a:t>
+              <a:t>Bidirectional UPI QR: Receiver can present QR for callers to pay directly.</a:t>
             </a:r>
           </a:p>
         </p:txBody>
@@ -3640,7 +3640,7 @@
                 </a:solidFill>
                 <a:latin typeface="Aptos"/>
               </a:rPr>
-              <a:t>Bharat Dues • 2026-04-16</a:t>
+              <a:t>Bharat Dues • 2026-04-26</a:t>
             </a:r>
           </a:p>
         </p:txBody>
@@ -3788,7 +3788,7 @@
                 </a:solidFill>
                 <a:latin typeface="Aptos"/>
               </a:rPr>
-              <a:t>Search expenses inside a group for quick audits</a:t>
+              <a:t>Interactive Activity: Inline confirm receipt and WhatsApp notifications.</a:t>
             </a:r>
           </a:p>
         </p:txBody>
@@ -3907,7 +3907,7 @@
                 </a:solidFill>
                 <a:latin typeface="Aptos"/>
               </a:rPr>
-              <a:t>Bharat Dues • 2026-04-16</a:t>
+              <a:t>Bharat Dues • 2026-04-26</a:t>
             </a:r>
           </a:p>
         </p:txBody>
@@ -4071,7 +4071,7 @@
                 </a:solidFill>
                 <a:latin typeface="Aptos"/>
               </a:rPr>
-              <a:t>Firestore streams for real-time sync and consistent UI state</a:t>
+              <a:t>Enhanced Identity Sync via Registries for reliability and consistent UI state</a:t>
             </a:r>
           </a:p>
         </p:txBody>
@@ -4190,7 +4190,7 @@
                 </a:solidFill>
                 <a:latin typeface="Aptos"/>
               </a:rPr>
-              <a:t>Bharat Dues • 2026-04-16</a:t>
+              <a:t>Bharat Dues • 2026-04-26</a:t>
             </a:r>
           </a:p>
         </p:txBody>
@@ -4473,7 +4473,7 @@
                 </a:solidFill>
                 <a:latin typeface="Aptos"/>
               </a:rPr>
-              <a:t>Bharat Dues • 2026-04-16</a:t>
+              <a:t>Bharat Dues • 2026-04-26</a:t>
             </a:r>
           </a:p>
         </p:txBody>
@@ -4738,7 +4738,7 @@
                 </a:solidFill>
                 <a:latin typeface="Aptos"/>
               </a:rPr>
-              <a:t>Bharat Dues • 2026-04-16</a:t>
+              <a:t>Bharat Dues • 2026-04-26</a:t>
             </a:r>
           </a:p>
         </p:txBody>
@@ -5005,7 +5005,7 @@
                 </a:solidFill>
                 <a:latin typeface="Aptos"/>
               </a:rPr>
-              <a:t>Bharat Dues • 2026-04-16</a:t>
+              <a:t>Bharat Dues • 2026-04-26</a:t>
             </a:r>
           </a:p>
         </p:txBody>
@@ -5272,7 +5272,7 @@
                 </a:solidFill>
                 <a:latin typeface="Aptos"/>
               </a:rPr>
-              <a:t>Bharat Dues • 2026-04-16</a:t>
+              <a:t>Bharat Dues • 2026-04-26</a:t>
             </a:r>
           </a:p>
         </p:txBody>
@@ -5555,7 +5555,7 @@
                 </a:solidFill>
                 <a:latin typeface="Aptos"/>
               </a:rPr>
-              <a:t>Bharat Dues • 2026-04-16</a:t>
+              <a:t>Bharat Dues • 2026-04-26</a:t>
             </a:r>
           </a:p>
         </p:txBody>
@@ -5671,7 +5671,7 @@
                 </a:solidFill>
                 <a:latin typeface="Aptos"/>
               </a:rPr>
-              <a:t>Shows your overall net position: You owe vs You are owed</a:t>
+              <a:t>Shows standardized net position: You owe vs You are owed (Premium)</a:t>
             </a:r>
           </a:p>
           <a:p>
@@ -5703,7 +5703,7 @@
                 </a:solidFill>
                 <a:latin typeface="Aptos"/>
               </a:rPr>
-              <a:t>Quick actions: edit profile (UPI/phone), create a new group, sign out</a:t>
+              <a:t>Web/PWA Optimized dashboard with quick actions: edit profile (UPI/phone), create a new group, sign out</a:t>
             </a:r>
           </a:p>
         </p:txBody>
@@ -5822,7 +5822,7 @@
                 </a:solidFill>
                 <a:latin typeface="Aptos"/>
               </a:rPr>
-              <a:t>Bharat Dues • 2026-04-16</a:t>
+              <a:t>Bharat Dues • 2026-04-26</a:t>
             </a:r>
           </a:p>
         </p:txBody>
@@ -5954,7 +5954,7 @@
                 </a:solidFill>
                 <a:latin typeface="Aptos"/>
               </a:rPr>
-              <a:t>Members are stored with identifiers (UID and/or phone) for reliable lookup and access</a:t>
+              <a:t>Members are stored with identifiers (UID, phone, and email) for reliable lookup and access</a:t>
             </a:r>
           </a:p>
           <a:p>
@@ -5970,7 +5970,7 @@
                 </a:solidFill>
                 <a:latin typeface="Aptos"/>
               </a:rPr>
-              <a:t>Group membership enables real-time collaboration: any member can add expenses</a:t>
+              <a:t>Enforces UPI edit restrictions for financial security: any member can add expenses</a:t>
             </a:r>
           </a:p>
         </p:txBody>
@@ -6089,7 +6089,7 @@
                 </a:solidFill>
                 <a:latin typeface="Aptos"/>
               </a:rPr>
-              <a:t>Bharat Dues • 2026-04-16</a:t>
+              <a:t>Bharat Dues • 2026-04-26</a:t>
             </a:r>
           </a:p>
         </p:txBody>
@@ -6372,7 +6372,7 @@
                 </a:solidFill>
                 <a:latin typeface="Aptos"/>
               </a:rPr>
-              <a:t>Bharat Dues • 2026-04-16</a:t>
+              <a:t>Bharat Dues • 2026-04-26</a:t>
             </a:r>
           </a:p>
         </p:txBody>

</xml_diff>